<commit_message>
Add ArxivLens logo to README and presentation
- Copy mipmap-xxxhdpi/ic_launcher.png to docs/logo.png
- Center logo in README header above the title
- Add logo to presentation title slide (slide 1) and summary slide (slide 18)
- Regenerate ArxivLens_Presentation.pptx with updated logo placement
</commit_message>
<xml_diff>
--- a/docs/ArxivLens_Presentation.pptx
+++ b/docs/ArxivLens_Presentation.pptx
@@ -2456,16 +2456,40 @@
           </a:ln>
         </p:spPr>
       </p:sp>
-      <p:sp>
-        <p:nvSpPr>
-          <p:cNvPr id="5" name="Text 3"/>
-          <p:cNvSpPr/>
-          <p:nvPr/>
-        </p:nvSpPr>
-        <p:spPr>
-          <a:xfrm>
-            <a:off x="0" y="1463040"/>
-            <a:ext cx="12188952" cy="1463040"/>
+      <p:pic>
+        <p:nvPicPr>
+          <p:cNvPr id="5" name="Image 0" descr="/Users/pavan/AndroidStudioProjects/ArxivLens/docs/logo.png">    </p:cNvPr>
+          <p:cNvPicPr>
+            <a:picLocks noChangeAspect="1"/>
+          </p:cNvPicPr>
+          <p:nvPr/>
+        </p:nvPicPr>
+        <p:blipFill>
+          <a:blip r:embed="rId1"/>
+          <a:stretch>
+            <a:fillRect/>
+          </a:stretch>
+        </p:blipFill>
+        <p:spPr>
+          <a:xfrm>
+            <a:off x="5500116" y="822960"/>
+            <a:ext cx="1188720" cy="1188720"/>
+          </a:xfrm>
+          <a:prstGeom prst="rect">
+            <a:avLst/>
+          </a:prstGeom>
+        </p:spPr>
+      </p:pic>
+      <p:sp>
+        <p:nvSpPr>
+          <p:cNvPr id="6" name="Text 3"/>
+          <p:cNvSpPr/>
+          <p:nvPr/>
+        </p:nvSpPr>
+        <p:spPr>
+          <a:xfrm>
+            <a:off x="0" y="2103120"/>
+            <a:ext cx="12188952" cy="1097280"/>
           </a:xfrm>
           <a:prstGeom prst="rect">
             <a:avLst/>
@@ -2481,7 +2505,7 @@
               <a:buNone/>
             </a:pPr>
             <a:r>
-              <a:rPr lang="en-US" sz="6800" b="1" dirty="0">
+              <a:rPr lang="en-US" sz="6400" b="1" dirty="0">
                 <a:solidFill>
                   <a:srgbClr val="FFFFFF"/>
                 </a:solidFill>
@@ -2491,19 +2515,19 @@
               </a:rPr>
               <a:t>ArxivLens</a:t>
             </a:r>
-            <a:endParaRPr lang="en-US" sz="6800" dirty="0"/>
-          </a:p>
-        </p:txBody>
-      </p:sp>
-      <p:sp>
-        <p:nvSpPr>
-          <p:cNvPr id="6" name="Shape 4"/>
-          <p:cNvSpPr/>
-          <p:nvPr/>
-        </p:nvSpPr>
-        <p:spPr>
-          <a:xfrm>
-            <a:off x="3717036" y="2926080"/>
+            <a:endParaRPr lang="en-US" sz="6400" dirty="0"/>
+          </a:p>
+        </p:txBody>
+      </p:sp>
+      <p:sp>
+        <p:nvSpPr>
+          <p:cNvPr id="7" name="Shape 4"/>
+          <p:cNvSpPr/>
+          <p:nvPr/>
+        </p:nvSpPr>
+        <p:spPr>
+          <a:xfrm>
+            <a:off x="3717036" y="3218688"/>
             <a:ext cx="4754880" cy="64008"/>
           </a:xfrm>
           <a:prstGeom prst="rect">
@@ -2522,13 +2546,13 @@
       </p:sp>
       <p:sp>
         <p:nvSpPr>
-          <p:cNvPr id="7" name="Text 5"/>
-          <p:cNvSpPr/>
-          <p:nvPr/>
-        </p:nvSpPr>
-        <p:spPr>
-          <a:xfrm>
-            <a:off x="1371600" y="3063240"/>
+          <p:cNvPr id="8" name="Text 5"/>
+          <p:cNvSpPr/>
+          <p:nvPr/>
+        </p:nvSpPr>
+        <p:spPr>
+          <a:xfrm>
+            <a:off x="1371600" y="3337560"/>
             <a:ext cx="9445752" cy="685800"/>
           </a:xfrm>
           <a:prstGeom prst="rect">
@@ -2561,13 +2585,13 @@
       </p:sp>
       <p:sp>
         <p:nvSpPr>
-          <p:cNvPr id="8" name="Text 6"/>
-          <p:cNvSpPr/>
-          <p:nvPr/>
-        </p:nvSpPr>
-        <p:spPr>
-          <a:xfrm>
-            <a:off x="0" y="3977640"/>
+          <p:cNvPr id="9" name="Text 6"/>
+          <p:cNvSpPr/>
+          <p:nvPr/>
+        </p:nvSpPr>
+        <p:spPr>
+          <a:xfrm>
+            <a:off x="0" y="4251960"/>
             <a:ext cx="12188952" cy="411480"/>
           </a:xfrm>
           <a:prstGeom prst="rect">
@@ -2614,13 +2638,13 @@
       </p:sp>
       <p:sp>
         <p:nvSpPr>
-          <p:cNvPr id="9" name="Text 7"/>
-          <p:cNvSpPr/>
-          <p:nvPr/>
-        </p:nvSpPr>
-        <p:spPr>
-          <a:xfrm>
-            <a:off x="0" y="4434840"/>
+          <p:cNvPr id="10" name="Text 7"/>
+          <p:cNvSpPr/>
+          <p:nvPr/>
+        </p:nvSpPr>
+        <p:spPr>
+          <a:xfrm>
+            <a:off x="0" y="4709160"/>
             <a:ext cx="12188952" cy="411480"/>
           </a:xfrm>
           <a:prstGeom prst="rect">
@@ -2667,13 +2691,13 @@
       </p:sp>
       <p:sp>
         <p:nvSpPr>
-          <p:cNvPr id="10" name="Text 8"/>
-          <p:cNvSpPr/>
-          <p:nvPr/>
-        </p:nvSpPr>
-        <p:spPr>
-          <a:xfrm>
-            <a:off x="0" y="4892040"/>
+          <p:cNvPr id="11" name="Text 8"/>
+          <p:cNvSpPr/>
+          <p:nvPr/>
+        </p:nvSpPr>
+        <p:spPr>
+          <a:xfrm>
+            <a:off x="0" y="5166360"/>
             <a:ext cx="12188952" cy="411480"/>
           </a:xfrm>
           <a:prstGeom prst="rect">
@@ -12537,9 +12561,33 @@
           </a:ln>
         </p:spPr>
       </p:sp>
-      <p:sp>
-        <p:nvSpPr>
-          <p:cNvPr id="5" name="Text 3"/>
+      <p:pic>
+        <p:nvPicPr>
+          <p:cNvPr id="5" name="Image 0" descr="/Users/pavan/AndroidStudioProjects/ArxivLens/docs/logo.png">    </p:cNvPr>
+          <p:cNvPicPr>
+            <a:picLocks noChangeAspect="1"/>
+          </p:cNvPicPr>
+          <p:nvPr/>
+        </p:nvPicPr>
+        <p:blipFill>
+          <a:blip r:embed="rId1"/>
+          <a:stretch>
+            <a:fillRect/>
+          </a:stretch>
+        </p:blipFill>
+        <p:spPr>
+          <a:xfrm>
+            <a:off x="3442716" y="164592"/>
+            <a:ext cx="658368" cy="658368"/>
+          </a:xfrm>
+          <a:prstGeom prst="rect">
+            <a:avLst/>
+          </a:prstGeom>
+        </p:spPr>
+      </p:pic>
+      <p:sp>
+        <p:nvSpPr>
+          <p:cNvPr id="6" name="Text 3"/>
           <p:cNvSpPr/>
           <p:nvPr/>
         </p:nvSpPr>
@@ -12578,7 +12626,7 @@
       </p:sp>
       <p:sp>
         <p:nvSpPr>
-          <p:cNvPr id="6" name="Shape 4"/>
+          <p:cNvPr id="7" name="Shape 4"/>
           <p:cNvSpPr/>
           <p:nvPr/>
         </p:nvSpPr>
@@ -12603,7 +12651,7 @@
       </p:sp>
       <p:sp>
         <p:nvSpPr>
-          <p:cNvPr id="7" name="Text 5"/>
+          <p:cNvPr id="8" name="Text 5"/>
           <p:cNvSpPr/>
           <p:nvPr/>
         </p:nvSpPr>
@@ -12645,7 +12693,7 @@
       </p:sp>
       <p:sp>
         <p:nvSpPr>
-          <p:cNvPr id="8" name="Shape 6"/>
+          <p:cNvPr id="9" name="Shape 6"/>
           <p:cNvSpPr/>
           <p:nvPr/>
         </p:nvSpPr>
@@ -12670,7 +12718,7 @@
       </p:sp>
       <p:sp>
         <p:nvSpPr>
-          <p:cNvPr id="9" name="Text 7"/>
+          <p:cNvPr id="10" name="Text 7"/>
           <p:cNvSpPr/>
           <p:nvPr/>
         </p:nvSpPr>

</xml_diff>